<commit_message>
Refresh deck screenshot and test counts
</commit_message>
<xml_diff>
--- a/docs/Faisla-Presentation.pptx
+++ b/docs/Faisla-Presentation.pptx
@@ -115,39 +115,39 @@
   <p:extLst>
     <p:ext uri="{521415D9-36F7-43E2-AB2F-B90AF26B5E84}">
       <p14:sectionLst xmlns:p14="http://schemas.microsoft.com/office/powerpoint/2010/main">
-        <p14:section name="Opening" id="{a4653afa-529b-9e7c-46cf-ba27876694b5}">
+        <p14:section name="Opening" id="{027f65ba-80e9-90fc-2b87-64200ebe66ee}">
           <p14:sldIdLst>
             <p14:sldId id="256"/>
           </p14:sldIdLst>
         </p14:section>
-        <p14:section name="Problem" id="{498c3d54-29f3-385c-301e-fe13664fe1d3}">
+        <p14:section name="Problem" id="{97704736-abf5-cb8e-1701-260a10a462fa}">
           <p14:sldIdLst>
             <p14:sldId id="257"/>
           </p14:sldIdLst>
         </p14:section>
-        <p14:section name="Data and AI" id="{5ee5b52f-d0fd-8d24-f55e-71db51a8f9d6}">
+        <p14:section name="Data and AI" id="{0ca838a2-0318-d896-67b9-afd2ff87c938}">
           <p14:sldIdLst>
             <p14:sldId id="258"/>
           </p14:sldIdLst>
         </p14:section>
-        <p14:section name="Solution" id="{82408cf2-ba01-dc9e-0bf4-18ee0d77c363}">
+        <p14:section name="Solution" id="{9204b95f-6d7b-8c99-93d8-7db2f9ccf543}">
           <p14:sldIdLst>
             <p14:sldId id="259"/>
             <p14:sldId id="260"/>
           </p14:sldIdLst>
         </p14:section>
-        <p14:section name="Impact" id="{8a942cf4-ba92-bcf2-5e39-e21c07d44585}">
+        <p14:section name="Impact" id="{d59d5dac-cc59-2e2e-2406-178fb0269287}">
           <p14:sldIdLst>
             <p14:sldId id="261"/>
             <p14:sldId id="262"/>
           </p14:sldIdLst>
         </p14:section>
-        <p14:section name="Build and trust" id="{1516b890-1df7-775f-9f17-56d02dc8c413}">
+        <p14:section name="Build and trust" id="{7b17e072-c5ad-a9dc-2520-35adeb0f5ba8}">
           <p14:sldIdLst>
             <p14:sldId id="263"/>
           </p14:sldIdLst>
         </p14:section>
-        <p14:section name="Close" id="{51e5f2e1-f34c-e980-6352-f03cd9388a91}">
+        <p14:section name="Close" id="{004ffeb1-1f07-0cda-890d-14d6fecbe5ba}">
           <p14:sldIdLst>
             <p14:sldId id="264"/>
           </p14:sldIdLst>
@@ -1192,7 +1192,7 @@
             <a:r>
               <a:rPr lang="en-US" dirty="0"/>
               <a:t>[4:00–4:35 · 35 s]
-Everything here was built during AICON’26; the commit history starts on the tenth of October. We built the finance engine in pure TypeScript, nine AI tasks each followed by a code check, the fraud rules, the email loop, and the app on Next.js, MongoDB Atlas and Vercel. 145 automated tests pin every number you saw.
+Everything here was built during AICON’26; the commit history starts on the tenth of October. We built the finance engine in pure TypeScript, nine AI tasks each followed by a code check, the fraud rules, the email loop, and the app on Next.js, MongoDB Atlas and Vercel. 194 automated tests pin every number you saw.
 Honest disclosure: the company, supplier names and benchmark are simulated and labelled; market prices and reviews are real, with links. We used AI coding assistants, as the rules allow.</a:t>
             </a:r>
             <a:endParaRPr lang="en-US" dirty="0"/>
@@ -4530,7 +4530,7 @@
                   <a:schemeClr val="tx1"/>
                 </a:solidFill>
               </a:rPr>
-              <a:t>145 automated tests</a:t>
+              <a:t>194 automated tests</a:t>
             </a:r>
             <a:endParaRPr lang="en-US" sz="1500" dirty="0"/>
           </a:p>
@@ -10321,7 +10321,7 @@
                 <a:ea typeface="Consolas" pitchFamily="34" charset="-122"/>
                 <a:cs typeface="Consolas" pitchFamily="34" charset="-120"/>
               </a:rPr>
-              <a:t>145</a:t>
+              <a:t>194</a:t>
             </a:r>
             <a:endParaRPr lang="en-US" sz="3600" dirty="0"/>
           </a:p>

</xml_diff>

<commit_message>
Update deck for the simpler flow, own choice and checked search; add PDF
</commit_message>
<xml_diff>
--- a/docs/Faisla-Presentation.pptx
+++ b/docs/Faisla-Presentation.pptx
@@ -115,39 +115,39 @@
   <p:extLst>
     <p:ext uri="{521415D9-36F7-43E2-AB2F-B90AF26B5E84}">
       <p14:sectionLst xmlns:p14="http://schemas.microsoft.com/office/powerpoint/2010/main">
-        <p14:section name="Opening" id="{027f65ba-80e9-90fc-2b87-64200ebe66ee}">
+        <p14:section name="Opening" id="{3c216d85-a9b5-3c51-9f92-584c234641c0}">
           <p14:sldIdLst>
             <p14:sldId id="256"/>
           </p14:sldIdLst>
         </p14:section>
-        <p14:section name="Problem" id="{97704736-abf5-cb8e-1701-260a10a462fa}">
+        <p14:section name="Problem" id="{0d574083-e298-b30b-bb33-c80c492b17ec}">
           <p14:sldIdLst>
             <p14:sldId id="257"/>
           </p14:sldIdLst>
         </p14:section>
-        <p14:section name="Data and AI" id="{0ca838a2-0318-d896-67b9-afd2ff87c938}">
+        <p14:section name="Data and AI" id="{713ff98d-0199-bb8e-73e5-b0f49d6dfc22}">
           <p14:sldIdLst>
             <p14:sldId id="258"/>
           </p14:sldIdLst>
         </p14:section>
-        <p14:section name="Solution" id="{9204b95f-6d7b-8c99-93d8-7db2f9ccf543}">
+        <p14:section name="Solution" id="{45c7e63b-3dae-6005-4ec3-4730434190f1}">
           <p14:sldIdLst>
             <p14:sldId id="259"/>
             <p14:sldId id="260"/>
           </p14:sldIdLst>
         </p14:section>
-        <p14:section name="Impact" id="{d59d5dac-cc59-2e2e-2406-178fb0269287}">
+        <p14:section name="Impact" id="{dfb0ee9d-af30-7c7f-6f9e-9bbbea0e3a79}">
           <p14:sldIdLst>
             <p14:sldId id="261"/>
             <p14:sldId id="262"/>
           </p14:sldIdLst>
         </p14:section>
-        <p14:section name="Build and trust" id="{7b17e072-c5ad-a9dc-2520-35adeb0f5ba8}">
+        <p14:section name="Build and trust" id="{764b71bd-f249-03ea-d3f0-c801d45553ea}">
           <p14:sldIdLst>
             <p14:sldId id="263"/>
           </p14:sldIdLst>
         </p14:section>
-        <p14:section name="Close" id="{004ffeb1-1f07-0cda-890d-14d6fecbe5ba}">
+        <p14:section name="Close" id="{a9b4bc96-30de-4145-9ffa-131311b2dc7d}">
           <p14:sldIdLst>
             <p14:sldId id="264"/>
           </p14:sldIdLst>
@@ -829,10 +829,11 @@
             <a:r>
               <a:rPr lang="en-US" dirty="0"/>
               <a:t>[1:40–2:28 · 48 s]  (Live option: show these three moments on the seeded decision “80 × Jack F5 lockstitch machines” in the app instead of this slide; keep to 48 s.)
-Here is Hamza’s result. Faisla checked the market: the quote is about 9% above our benchmark, and real OLX listings put the median at seventy thousand a machine. It found Supplier B, who replied in Roman Urdu at sixty-seven thousand. Then code compared every way to pay.
+Here is Hamza’s result. Faisla checked the market: the quote is about 9% above our benchmark, and three real listings put the median at seventy thousand a machine. It found Supplier B, who replied in Roman Urdu at sixty-seven thousand. Then code compared every way to pay.
 Three money moments. One: the “0%” plan is a deferred-price sale; paying later costs 16.9% a year.
 Two: Hamza is an exporter, so SBP’s Islamic LTFF at 8.5% wins, and Faisla recommends it.
-Three: an email arrives saying “our bank account has changed, pay today”. Faisla flags the new IBAN, the wrong account title and the Gmail address, and blocks payment until Hamza confirms by phone.</a:t>
+Three: an email arrives saying “our bank account has changed, pay today”. Faisla flags the new IBAN, the wrong account title and the Gmail address, and blocks payment until Hamza confirms by phone.
+And Hamza stays in charge: he can choose any row. If he prefers Ijarah, Faisla says it costs one point seven seven lakh more, then writes the memo and the bank request for his choice.</a:t>
             </a:r>
             <a:endParaRPr lang="en-US" dirty="0"/>
           </a:p>
@@ -1192,7 +1193,7 @@
             <a:r>
               <a:rPr lang="en-US" dirty="0"/>
               <a:t>[4:00–4:35 · 35 s]
-Everything here was built during AICON’26; the commit history starts on the tenth of October. We built the finance engine in pure TypeScript, nine AI tasks each followed by a code check, the fraud rules, the email loop, and the app on Next.js, MongoDB Atlas and Vercel. 194 automated tests pin every number you saw.
+Everything here was built during AICON’26; the commit history starts on the tenth of October. We built the finance engine in pure TypeScript, AI tasks each followed by a code check, the fraud rules, a spec-checked web search with paste-your-own-link, the email loop, owner-chosen options, and the app on Next.js, MongoDB Atlas and Vercel. 194 automated tests pin every number you saw.
 Honest disclosure: the company, supplier names and benchmark are simulated and labelled; market prices and reviews are real, with links. We used AI coding assistants, as the rules allow.</a:t>
             </a:r>
             <a:endParaRPr lang="en-US" dirty="0"/>
@@ -4298,7 +4299,7 @@
                   <a:schemeClr val="tx1"/>
                 </a:solidFill>
               </a:rPr>
-              <a:t>Writes RFQ emails and the memo</a:t>
+              <a:t>Writes price requests and the memo</a:t>
             </a:r>
             <a:endParaRPr lang="en-US" sz="1500" dirty="0"/>
           </a:p>
@@ -5195,7 +5196,7 @@
                   <a:schemeClr val="accent4"/>
                 </a:solidFill>
               </a:rPr>
-              <a:t>Live app, seeded demo decision: Supplier B found via a Roman Urdu reply at Rs 67,000 a machine</a:t>
+              <a:t>Live app: the answer first, then every way to pay. The owner can choose any row.</a:t>
             </a:r>
             <a:endParaRPr lang="en-US" sz="1100" dirty="0"/>
           </a:p>
@@ -9503,7 +9504,7 @@
                   <a:schemeClr val="tx1"/>
                 </a:solidFill>
               </a:rPr>
-              <a:t>9 AI tasks, each followed by a code check</a:t>
+              <a:t>Every AI task followed by a code check</a:t>
             </a:r>
             <a:endParaRPr lang="en-US" sz="1600" dirty="0"/>
           </a:p>
@@ -9539,7 +9540,7 @@
                   <a:schemeClr val="tx1"/>
                 </a:solidFill>
               </a:rPr>
-              <a:t>Email loop: RFQs out, replies read</a:t>
+              <a:t>Spec-checked web search + paste your own link</a:t>
             </a:r>
             <a:endParaRPr lang="en-US" sz="1600" dirty="0"/>
           </a:p>
@@ -9557,7 +9558,7 @@
                   <a:schemeClr val="tx1"/>
                 </a:solidFill>
               </a:rPr>
-              <a:t>5-step decision workspace + dashboard</a:t>
+              <a:t>Choose any option: memo + bank request follow</a:t>
             </a:r>
             <a:endParaRPr lang="en-US" sz="1600" dirty="0"/>
           </a:p>

</xml_diff>